<commit_message>
Deck: add reviewer-feedback coverage slide, tighten to 14 slides
Slide 2 now maps each point of the review feedback to the slide that
answers it (architecture, worked example, meta-labeling, broader
experiments, exposure control, walk-forward, reproducibility).

Co-Authored-By: Claude Opus 4.8 (1M context) <noreply@anthropic.com>
</commit_message>
<xml_diff>
--- a/presentation/SSGA_Deliverables_Deck.pptx
+++ b/presentation/SSGA_Deliverables_Deck.pptx
@@ -6800,7 +6800,7 @@
               </a:defRPr>
             </a:pPr>
             <a:r>
-              <a:t>WHAT THIS DECK DELIVERS</a:t>
+              <a:t>SCOPE OF THIS UPDATE</a:t>
             </a:r>
           </a:p>
         </p:txBody>
@@ -6838,7 +6838,7 @@
               </a:defRPr>
             </a:pPr>
             <a:r>
-              <a:t>Four deliverables, one authoritative run</a:t>
+              <a:t>Your feedback — where each point is addressed</a:t>
             </a:r>
           </a:p>
         </p:txBody>
@@ -6887,16 +6887,426 @@
           </a:p>
         </p:txBody>
       </p:sp>
-      <p:sp>
-        <p:nvSpPr>
-          <p:cNvPr id="6" name="TextBox 5"/>
+      <p:graphicFrame>
+        <p:nvGraphicFramePr>
+          <p:cNvPr id="6" name="Table 5"/>
+          <p:cNvGraphicFramePr>
+            <a:graphicFrameLocks noGrp="1"/>
+          </p:cNvGraphicFramePr>
+          <p:nvPr/>
+        </p:nvGraphicFramePr>
+        <p:xfrm>
+          <a:off x="640080" y="1600200"/>
+          <a:ext cx="10908792" cy="3072384"/>
+        </p:xfrm>
+        <a:graphic>
+          <a:graphicData uri="http://schemas.openxmlformats.org/drawingml/2006/table">
+            <a:tbl>
+              <a:tblPr firstRow="1" bandRow="1">
+                <a:tableStyleId>{5C22544A-7EE6-4342-B048-85BDC9FD1C3A}</a:tableStyleId>
+              </a:tblPr>
+              <a:tblGrid>
+                <a:gridCol w="5454396"/>
+                <a:gridCol w="5454396"/>
+              </a:tblGrid>
+              <a:tr h="384048">
+                <a:tc>
+                  <a:txBody>
+                    <a:bodyPr/>
+                    <a:lstStyle/>
+                    <a:p>
+                      <a:pPr>
+                        <a:defRPr sz="1200" b="1">
+                          <a:solidFill>
+                            <a:srgbClr val="FFFFFF"/>
+                          </a:solidFill>
+                        </a:defRPr>
+                      </a:pPr>
+                      <a:r>
+                        <a:t>Feedback from the review</a:t>
+                      </a:r>
+                    </a:p>
+                  </a:txBody>
+                  <a:tcPr>
+                    <a:solidFill>
+                      <a:srgbClr val="0B2A4A"/>
+                    </a:solidFill>
+                  </a:tcPr>
+                </a:tc>
+                <a:tc>
+                  <a:txBody>
+                    <a:bodyPr/>
+                    <a:lstStyle/>
+                    <a:p>
+                      <a:pPr>
+                        <a:defRPr sz="1200" b="1">
+                          <a:solidFill>
+                            <a:srgbClr val="FFFFFF"/>
+                          </a:solidFill>
+                        </a:defRPr>
+                      </a:pPr>
+                      <a:r>
+                        <a:t>Addressed on</a:t>
+                      </a:r>
+                    </a:p>
+                  </a:txBody>
+                  <a:tcPr>
+                    <a:solidFill>
+                      <a:srgbClr val="0B2A4A"/>
+                    </a:solidFill>
+                  </a:tcPr>
+                </a:tc>
+              </a:tr>
+              <a:tr h="384048">
+                <a:tc>
+                  <a:txBody>
+                    <a:bodyPr/>
+                    <a:lstStyle/>
+                    <a:p>
+                      <a:pPr>
+                        <a:defRPr sz="1150">
+                          <a:solidFill>
+                            <a:srgbClr val="0B2A4A"/>
+                          </a:solidFill>
+                        </a:defRPr>
+                      </a:pPr>
+                      <a:r>
+                        <a:t>1 · Complete M1–M2–M3 architecture (inputs, outputs, training, inference)</a:t>
+                      </a:r>
+                    </a:p>
+                  </a:txBody>
+                  <a:tcPr>
+                    <a:solidFill>
+                      <a:srgbClr val="FFFFFF"/>
+                    </a:solidFill>
+                  </a:tcPr>
+                </a:tc>
+                <a:tc>
+                  <a:txBody>
+                    <a:bodyPr/>
+                    <a:lstStyle/>
+                    <a:p>
+                      <a:pPr>
+                        <a:defRPr sz="1150" b="1">
+                          <a:solidFill>
+                            <a:srgbClr val="1F6FB2"/>
+                          </a:solidFill>
+                        </a:defRPr>
+                      </a:pPr>
+                      <a:r>
+                        <a:t>Slides 3–4</a:t>
+                      </a:r>
+                    </a:p>
+                  </a:txBody>
+                  <a:tcPr>
+                    <a:solidFill>
+                      <a:srgbClr val="FFFFFF"/>
+                    </a:solidFill>
+                  </a:tcPr>
+                </a:tc>
+              </a:tr>
+              <a:tr h="384048">
+                <a:tc>
+                  <a:txBody>
+                    <a:bodyPr/>
+                    <a:lstStyle/>
+                    <a:p>
+                      <a:pPr>
+                        <a:defRPr sz="1150">
+                          <a:solidFill>
+                            <a:srgbClr val="0B2A4A"/>
+                          </a:solidFill>
+                        </a:defRPr>
+                      </a:pPr>
+                      <a:r>
+                        <a:t>2 · Worked numerical example — one asset to its final weight</a:t>
+                      </a:r>
+                    </a:p>
+                  </a:txBody>
+                  <a:tcPr>
+                    <a:solidFill>
+                      <a:srgbClr val="FFFFFF"/>
+                    </a:solidFill>
+                  </a:tcPr>
+                </a:tc>
+                <a:tc>
+                  <a:txBody>
+                    <a:bodyPr/>
+                    <a:lstStyle/>
+                    <a:p>
+                      <a:pPr>
+                        <a:defRPr sz="1150" b="1">
+                          <a:solidFill>
+                            <a:srgbClr val="1F6FB2"/>
+                          </a:solidFill>
+                        </a:defRPr>
+                      </a:pPr>
+                      <a:r>
+                        <a:t>Slide 8</a:t>
+                      </a:r>
+                    </a:p>
+                  </a:txBody>
+                  <a:tcPr>
+                    <a:solidFill>
+                      <a:srgbClr val="FFFFFF"/>
+                    </a:solidFill>
+                  </a:tcPr>
+                </a:tc>
+              </a:tr>
+              <a:tr h="384048">
+                <a:tc>
+                  <a:txBody>
+                    <a:bodyPr/>
+                    <a:lstStyle/>
+                    <a:p>
+                      <a:pPr>
+                        <a:defRPr sz="1150">
+                          <a:solidFill>
+                            <a:srgbClr val="0B2A4A"/>
+                          </a:solidFill>
+                        </a:defRPr>
+                      </a:pPr>
+                      <a:r>
+                        <a:t>3 · Stronger meta-labeling explanation (the five questions)</a:t>
+                      </a:r>
+                    </a:p>
+                  </a:txBody>
+                  <a:tcPr>
+                    <a:solidFill>
+                      <a:srgbClr val="FFFFFF"/>
+                    </a:solidFill>
+                  </a:tcPr>
+                </a:tc>
+                <a:tc>
+                  <a:txBody>
+                    <a:bodyPr/>
+                    <a:lstStyle/>
+                    <a:p>
+                      <a:pPr>
+                        <a:defRPr sz="1150" b="1">
+                          <a:solidFill>
+                            <a:srgbClr val="1F6FB2"/>
+                          </a:solidFill>
+                        </a:defRPr>
+                      </a:pPr>
+                      <a:r>
+                        <a:t>Slides 5–6</a:t>
+                      </a:r>
+                    </a:p>
+                  </a:txBody>
+                  <a:tcPr>
+                    <a:solidFill>
+                      <a:srgbClr val="FFFFFF"/>
+                    </a:solidFill>
+                  </a:tcPr>
+                </a:tc>
+              </a:tr>
+              <a:tr h="384048">
+                <a:tc>
+                  <a:txBody>
+                    <a:bodyPr/>
+                    <a:lstStyle/>
+                    <a:p>
+                      <a:pPr>
+                        <a:defRPr sz="1150">
+                          <a:solidFill>
+                            <a:srgbClr val="0B2A4A"/>
+                          </a:solidFill>
+                        </a:defRPr>
+                      </a:pPr>
+                      <a:r>
+                        <a:t>4 · Broader experimentation — M3 &amp; asset-allocation alternatives</a:t>
+                      </a:r>
+                    </a:p>
+                  </a:txBody>
+                  <a:tcPr>
+                    <a:solidFill>
+                      <a:srgbClr val="FFFFFF"/>
+                    </a:solidFill>
+                  </a:tcPr>
+                </a:tc>
+                <a:tc>
+                  <a:txBody>
+                    <a:bodyPr/>
+                    <a:lstStyle/>
+                    <a:p>
+                      <a:pPr>
+                        <a:defRPr sz="1150" b="1">
+                          <a:solidFill>
+                            <a:srgbClr val="1F6FB2"/>
+                          </a:solidFill>
+                        </a:defRPr>
+                      </a:pPr>
+                      <a:r>
+                        <a:t>Slides 9, 11–12</a:t>
+                      </a:r>
+                    </a:p>
+                  </a:txBody>
+                  <a:tcPr>
+                    <a:solidFill>
+                      <a:srgbClr val="FFFFFF"/>
+                    </a:solidFill>
+                  </a:tcPr>
+                </a:tc>
+              </a:tr>
+              <a:tr h="384048">
+                <a:tc>
+                  <a:txBody>
+                    <a:bodyPr/>
+                    <a:lstStyle/>
+                    <a:p>
+                      <a:pPr>
+                        <a:defRPr sz="1150">
+                          <a:solidFill>
+                            <a:srgbClr val="0B2A4A"/>
+                          </a:solidFill>
+                        </a:defRPr>
+                      </a:pPr>
+                      <a:r>
+                        <a:t>5 · Control for gross / net exposure or volatility (mechanical vs genuine)</a:t>
+                      </a:r>
+                    </a:p>
+                  </a:txBody>
+                  <a:tcPr>
+                    <a:solidFill>
+                      <a:srgbClr val="FFFFFF"/>
+                    </a:solidFill>
+                  </a:tcPr>
+                </a:tc>
+                <a:tc>
+                  <a:txBody>
+                    <a:bodyPr/>
+                    <a:lstStyle/>
+                    <a:p>
+                      <a:pPr>
+                        <a:defRPr sz="1150" b="1">
+                          <a:solidFill>
+                            <a:srgbClr val="1F6FB2"/>
+                          </a:solidFill>
+                        </a:defRPr>
+                      </a:pPr>
+                      <a:r>
+                        <a:t>Slide 10</a:t>
+                      </a:r>
+                    </a:p>
+                  </a:txBody>
+                  <a:tcPr>
+                    <a:solidFill>
+                      <a:srgbClr val="FFFFFF"/>
+                    </a:solidFill>
+                  </a:tcPr>
+                </a:tc>
+              </a:tr>
+              <a:tr h="384048">
+                <a:tc>
+                  <a:txBody>
+                    <a:bodyPr/>
+                    <a:lstStyle/>
+                    <a:p>
+                      <a:pPr>
+                        <a:defRPr sz="1150">
+                          <a:solidFill>
+                            <a:srgbClr val="0B2A4A"/>
+                          </a:solidFill>
+                        </a:defRPr>
+                      </a:pPr>
+                      <a:r>
+                        <a:t>6 · Walk-forward testing across multiple market periods</a:t>
+                      </a:r>
+                    </a:p>
+                  </a:txBody>
+                  <a:tcPr>
+                    <a:solidFill>
+                      <a:srgbClr val="FFFFFF"/>
+                    </a:solidFill>
+                  </a:tcPr>
+                </a:tc>
+                <a:tc>
+                  <a:txBody>
+                    <a:bodyPr/>
+                    <a:lstStyle/>
+                    <a:p>
+                      <a:pPr>
+                        <a:defRPr sz="1150" b="1">
+                          <a:solidFill>
+                            <a:srgbClr val="1F6FB2"/>
+                          </a:solidFill>
+                        </a:defRPr>
+                      </a:pPr>
+                      <a:r>
+                        <a:t>Slides 10–12</a:t>
+                      </a:r>
+                    </a:p>
+                  </a:txBody>
+                  <a:tcPr>
+                    <a:solidFill>
+                      <a:srgbClr val="FFFFFF"/>
+                    </a:solidFill>
+                  </a:tcPr>
+                </a:tc>
+              </a:tr>
+              <a:tr h="384048">
+                <a:tc>
+                  <a:txBody>
+                    <a:bodyPr/>
+                    <a:lstStyle/>
+                    <a:p>
+                      <a:pPr>
+                        <a:defRPr sz="1150">
+                          <a:solidFill>
+                            <a:srgbClr val="0B2A4A"/>
+                          </a:solidFill>
+                        </a:defRPr>
+                      </a:pPr>
+                      <a:r>
+                        <a:t>7 · One authoritative, reproducible set of results</a:t>
+                      </a:r>
+                    </a:p>
+                  </a:txBody>
+                  <a:tcPr>
+                    <a:solidFill>
+                      <a:srgbClr val="FFFFFF"/>
+                    </a:solidFill>
+                  </a:tcPr>
+                </a:tc>
+                <a:tc>
+                  <a:txBody>
+                    <a:bodyPr/>
+                    <a:lstStyle/>
+                    <a:p>
+                      <a:pPr>
+                        <a:defRPr sz="1150" b="1">
+                          <a:solidFill>
+                            <a:srgbClr val="1F6FB2"/>
+                          </a:solidFill>
+                        </a:defRPr>
+                      </a:pPr>
+                      <a:r>
+                        <a:t>Slide 13</a:t>
+                      </a:r>
+                    </a:p>
+                  </a:txBody>
+                  <a:tcPr>
+                    <a:solidFill>
+                      <a:srgbClr val="FFFFFF"/>
+                    </a:solidFill>
+                  </a:tcPr>
+                </a:tc>
+              </a:tr>
+            </a:tbl>
+          </a:graphicData>
+        </a:graphic>
+      </p:graphicFrame>
+      <p:sp>
+        <p:nvSpPr>
+          <p:cNvPr id="7" name="TextBox 6"/>
           <p:cNvSpPr txBox="1"/>
           <p:nvPr/>
         </p:nvSpPr>
         <p:spPr>
           <a:xfrm>
-            <a:off x="640080" y="1554480"/>
-            <a:ext cx="10972800" cy="3931920"/>
+            <a:off x="640080" y="4837175"/>
+            <a:ext cx="10881360" cy="1097280"/>
           </a:xfrm>
           <a:prstGeom prst="rect">
             <a:avLst/>
@@ -6911,165 +7321,23 @@
           <a:p>
             <a:pPr>
               <a:spcAft>
-                <a:spcPts val="500"/>
+                <a:spcPts val="0"/>
               </a:spcAft>
-              <a:defRPr sz="1600" b="1">
+              <a:defRPr sz="1300" b="0">
                 <a:solidFill>
-                  <a:srgbClr val="0B2A4A"/>
+                  <a:srgbClr val="555B66"/>
                 </a:solidFill>
               </a:defRPr>
             </a:pPr>
             <a:r>
-              <a:t>■  Deliverable 1 — A complete architecture diagram: the inputs, outputs, training and inference of M1, M2, M3 and the portfolio layer.</a:t>
-            </a:r>
-          </a:p>
-          <a:p>
-            <a:pPr>
-              <a:spcAft>
-                <a:spcPts val="500"/>
-              </a:spcAft>
-              <a:defRPr sz="1600" b="1">
-                <a:solidFill>
-                  <a:srgbClr val="0B2A4A"/>
-                </a:solidFill>
-              </a:defRPr>
-            </a:pPr>
-            <a:r>
-              <a:t>■  Deliverable 2 — A worked numerical example following one asset (SP500) through every stage to its final portfolio weight.</a:t>
-            </a:r>
-          </a:p>
-          <a:p>
-            <a:pPr>
-              <a:spcAft>
-                <a:spcPts val="500"/>
-              </a:spcAft>
-              <a:defRPr sz="1600" b="1">
-                <a:solidFill>
-                  <a:srgbClr val="0B2A4A"/>
-                </a:solidFill>
-              </a:defRPr>
-            </a:pPr>
-            <a:r>
-              <a:t>■  Deliverable 3 — A structured experimental matrix spanning M1 weights, asset allocations, M3 sizing functions, regime conditioning and cost-awareness.</a:t>
-            </a:r>
-          </a:p>
-          <a:p>
-            <a:pPr>
-              <a:spcAft>
-                <a:spcPts val="500"/>
-              </a:spcAft>
-              <a:defRPr sz="1600" b="1">
-                <a:solidFill>
-                  <a:srgbClr val="0B2A4A"/>
-                </a:solidFill>
-              </a:defRPr>
-            </a:pPr>
-            <a:r>
-              <a:t>■  Deliverable 4 — Exposure-controlled and walk-forward results that separate genuine model value from mechanical risk reduction.</a:t>
-            </a:r>
-          </a:p>
-          <a:p>
-            <a:pPr>
-              <a:spcAft>
-                <a:spcPts val="500"/>
-              </a:spcAft>
-              <a:defRPr sz="1600" b="1">
-                <a:solidFill>
-                  <a:srgbClr val="0B2A4A"/>
-                </a:solidFill>
-              </a:defRPr>
-            </a:pPr>
-            <a:r>
-              <a:t>■  Plus the two conceptual asks: a precise account of meta-labeling, and one reproducible set of results where every number traces to a config, data window and code version.</a:t>
-            </a:r>
-          </a:p>
-        </p:txBody>
-      </p:sp>
-      <p:sp>
-        <p:nvSpPr>
-          <p:cNvPr id="7" name="Rectangle 6"/>
-          <p:cNvSpPr/>
-          <p:nvPr/>
-        </p:nvSpPr>
-        <p:spPr>
-          <a:xfrm>
-            <a:off x="548640" y="5669280"/>
-            <a:ext cx="11091672" cy="603504"/>
-          </a:xfrm>
-          <a:prstGeom prst="rect">
-            <a:avLst/>
-          </a:prstGeom>
-          <a:solidFill>
-            <a:srgbClr val="ECF1F6"/>
-          </a:solidFill>
-          <a:ln>
-            <a:noFill/>
-          </a:ln>
-          <a:effectLst/>
-        </p:spPr>
-        <p:style>
-          <a:lnRef idx="1">
-            <a:schemeClr val="accent1"/>
-          </a:lnRef>
-          <a:fillRef idx="3">
-            <a:schemeClr val="accent1"/>
-          </a:fillRef>
-          <a:effectRef idx="2">
-            <a:schemeClr val="accent1"/>
-          </a:effectRef>
-          <a:fontRef idx="minor">
-            <a:schemeClr val="lt1"/>
-          </a:fontRef>
-        </p:style>
-        <p:txBody>
-          <a:bodyPr rtlCol="0" anchor="ctr"/>
-          <a:lstStyle/>
-          <a:p>
-            <a:pPr algn="ctr"/>
+              <a:t>Every requested item maps to a specific slide; all numbers come from reproduced, walk-forward runs.</a:t>
+            </a:r>
           </a:p>
         </p:txBody>
       </p:sp>
       <p:sp>
         <p:nvSpPr>
           <p:cNvPr id="8" name="TextBox 7"/>
-          <p:cNvSpPr txBox="1"/>
-          <p:nvPr/>
-        </p:nvSpPr>
-        <p:spPr>
-          <a:xfrm>
-            <a:off x="777240" y="5705856"/>
-            <a:ext cx="10698480" cy="530352"/>
-          </a:xfrm>
-          <a:prstGeom prst="rect">
-            <a:avLst/>
-          </a:prstGeom>
-          <a:noFill/>
-        </p:spPr>
-        <p:txBody>
-          <a:bodyPr wrap="square" anchor="ctr">
-            <a:spAutoFit/>
-          </a:bodyPr>
-          <a:lstStyle/>
-          <a:p>
-            <a:pPr>
-              <a:spcAft>
-                <a:spcPts val="0"/>
-              </a:spcAft>
-              <a:defRPr sz="1300" b="1">
-                <a:solidFill>
-                  <a:srgbClr val="1F6FB2"/>
-                </a:solidFill>
-              </a:defRPr>
-            </a:pPr>
-            <a:r>
-              <a:t>Takeaway:  This is treated as the beginning of the investigation, not a final verdict on meta-labeling or M3.</a:t>
-            </a:r>
-          </a:p>
-        </p:txBody>
-      </p:sp>
-      <p:sp>
-        <p:nvSpPr>
-          <p:cNvPr id="9" name="TextBox 8"/>
           <p:cNvSpPr txBox="1"/>
           <p:nvPr/>
         </p:nvSpPr>
@@ -7107,7 +7375,7 @@
       </p:sp>
       <p:sp>
         <p:nvSpPr>
-          <p:cNvPr id="10" name="TextBox 9"/>
+          <p:cNvPr id="9" name="TextBox 8"/>
           <p:cNvSpPr txBox="1"/>
           <p:nvPr/>
         </p:nvSpPr>

</xml_diff>